<commit_message>
Deliver Goal 005 evidence and local media with one verified Voice rescue
Record all eight consumed attempts, the final candidate's complete ordinary
Voice rescue, and its failed recovery sample without a remote ending ACK.
Keep the two-pass target unmet and preserve all historical accounting.

Deliver the Gallery demonstration, native pitch deck and PDF with actual
source provenance. Keep the MP4 local, public Live disabled and runtime/player
bytes identical to the frozen 2edf791 candidate.
</commit_message>
<xml_diff>
--- a/submission/Talk_Me_Home_Goal005_Pitch.pptx
+++ b/submission/Talk_Me_Home_Goal005_Pitch.pptx
@@ -507,7 +507,7 @@
           <a:lstStyle/>
           <a:p>
             <a:r>
-              <a:t>Existing original cover illustration, not a gameplay screenshot. Goal 005 versioned local draft. Final results are controlled by status.json; no public link is invented.</a:t>
+              <a:t>Existing original cover illustration, not a gameplay screenshot. Goal 005 local release media. Results are controlled by status.json; no public link is invented.</a:t>
             </a:r>
           </a:p>
         </p:txBody>
@@ -647,7 +647,7 @@
           <a:lstStyle/>
           <a:p>
             <a:r>
-              <a:t>Actual Goal 005 compiled Practice UI, artifacts/goal-005/ui/gallery-validation.json. Capture is deterministic offline gameplay, not real-model completion. Planned and explored routes are deliberate private player annotations. Both authored Gallery configurations and topology remain finite; no automatically solved safe path is drawn.</a:t>
+              <a:t>Actual final-build Goal 005 Practice UI, recorded separately from real Voice attempt 12. Capture is deterministic offline gameplay, not real-model completion. Planned and explored routes are deliberate private player annotations. Both authored Gallery configurations and topology remain finite; no automatically solved safe path is drawn. artifacts/goal-005/ui/final-planned-route.png</a:t>
             </a:r>
           </a:p>
         </p:txBody>
@@ -717,7 +717,7 @@
           <a:lstStyle/>
           <a:p>
             <a:r>
-              <a:t>Actual Practice screenshot at CSS 200% zoom, not a visual mockup. Exact saved messages and original report time/source are preserved. Report freshness is server-stamped at receipt; a Relay change and change-back cannot revive a gate reading. Selected quick requests are explicitly labelled Selected request, never microphone speech. Private associations do not enter robot context.</a:t>
+              <a:t>Actual final-build Practice screenshot, not a visual mockup. Exact saved messages and original report time/source are preserved. Report freshness is server-stamped at receipt; a Relay change and change-back cannot revive a gate reading. Selected quick requests are explicitly labelled Selected request, never microphone speech. Private associations do not enter robot context. artifacts/goal-005/ui/final-historical-dynamic-stable-clue.png</a:t>
             </a:r>
           </a:p>
         </p:txBody>
@@ -787,7 +787,7 @@
           <a:lstStyle/>
           <a:p>
             <a:r>
-              <a:t>Implemented Goal 005 product design; schema/adapter and compiled injected-provider tests establish local behavior, not a guarantee of real-model compliance. Arrival data is robot-eligible only and has no hidden global graph. Existing one-shot scheduler preserves safe tool/playback boundaries and cancellation. Final live efficacy must be supplied from completed batch evidence.</a:t>
+              <a:t>Actual server-confirmed home screenshot from synthetic-microphone real AssemblyAI Voice attempt 12. Build 2edf7914a008143843923b04a9bf3a1fe41f1f68. 11 exact UI-confirmed commits; local connected 577.2133s, provider-reported 576.923132s; ending ACK and cleanup observed. Arrival reports and bounded recovery helped this sample; permission questions and an empty response still occurred. One pass is not the required two or a statistical reliability guarantee. artifacts/goal-005/live/attempt-12-observed-home.png</a:t>
             </a:r>
           </a:p>
         </p:txBody>
@@ -857,7 +857,7 @@
           <a:lstStyle/>
           <a:p>
             <a:r>
-              <a:t>This slide must be updated from actual final-candidate results. Do not convert Practice, fake-peer tests, selected requests or historical failed calls into a Voice completion. No claim about human enjoyment, physical audio quality, revenue, customers or statistical reliability. Public URLs intentionally remain unset. {"phase": "IN_PROGRESS", "displayStatus": "Goal 005 draft \u00b7 live acceptance in progress", "acceptanceHeadline": "The final live result is still being established.", "acceptanceCopy": "Current images show deterministic Practice. Final-candidate Voice completion, recovery and ending evidence will replace this status after the approved batch.", "verifiedBuild": null, "publicDemoUrl": null, "uploadedVideoUrl": null, "evidencePath": "artifacts/goal-005/ui/gallery-validation.json", "uiCaptures": {"wide": "artifacts/goal-005/ui/goal-005-gallery-chromium-1440.png", "report": "artifacts/goal-005/ui/goal-005-gallery-zoom-chromium-1280.png"}}</a:t>
+              <a:t>Final batch result: one accepted Voice completion on final build; target of two not met. Attempt 13 stalled acquiring a Gallery passage report and had no ending ACK; local resources were cleaned up. All eight Goal 005 slots are consumed. Practice, fake-peer tests, selected requests and historical functional homes are not extra final-candidate passes. No claim about human enjoyment, physical audio quality, revenue, customers or statistical reliability. Public URLs intentionally remain unset. {"phase": "BATCH_COMPLETE_TARGET_NOT_MET", "displayStatus": "Goal 005 \u00b7 one final-candidate Voice pass", "acceptanceHeadline": "Home reached. Reliability still needs work.", "acceptanceCopy": "One final-candidate Voice rescue reached home with 11 exact confirmations and an ending ACK.\nA second run stalled in the Gallery without an ACK. The two-pass target remains unmet.", "verifiedBuild": "2edf7914a008143843923b04a9bf3a1fe41f1f68", "runtimeSha256": "bf8fe9ef044561064164cf537380559d1a5e92d06f290399d20c472cae6fa401", "acceptance": {"finalCandidatePasses": 1, "requiredPasses": 2, "goal005SlotsUsed": 8, "goal005SlotsRemaining": 0, "passAttempt": 12, "failedFinalAttempt": 13, "failedFinalAttemptEndAcknowledged": false}, "publicDemoUrl": null, "uploadedVideoUrl": null, "evidencePath": "docs/goal-005-gallery-live-completion.md", "uiCaptures": {"wide": "artifacts/goal-005/ui/final-planned-route.png", "report": "artifacts/goal-005/ui/final-historical-dynamic-stable-clue.png"}, "homeCapture": "artifacts/goal-005/live/attempt-12-observed-home.png", "mediaBoundary": "Separate labelled Practice UI capture and edited excerpts of only real attempt 12. Original synthetic-input/provider-playback audio retained; no generated narration or replacement speech. No human listening or physical-device verification claimed."}</a:t>
             </a:r>
           </a:p>
         </p:txBody>
@@ -4201,7 +4201,7 @@
               </a:defRPr>
             </a:pPr>
             <a:r>
-              <a:t>Goal 005 draft · live acceptance in progress</a:t>
+              <a:t>Goal 005 · one final-candidate Voice pass</a:t>
             </a:r>
           </a:p>
         </p:txBody>
@@ -4438,7 +4438,7 @@
               </a:defRPr>
             </a:pPr>
             <a:r>
-              <a:t>Goal 005 draft · live acceptance in progress</a:t>
+              <a:t>Goal 005 · one final-candidate Voice pass</a:t>
             </a:r>
           </a:p>
         </p:txBody>
@@ -5173,7 +5173,7 @@
               </a:defRPr>
             </a:pPr>
             <a:r>
-              <a:t>Goal 005 draft · live acceptance in progress</a:t>
+              <a:t>Goal 005 · one final-candidate Voice pass</a:t>
             </a:r>
           </a:p>
         </p:txBody>
@@ -5222,7 +5222,7 @@
       </p:sp>
       <p:pic>
         <p:nvPicPr>
-          <p:cNvPr id="8" name="Picture 7" descr="goal-005-gallery-chromium-1440.png"/>
+          <p:cNvPr id="8" name="Picture 7" descr="final-planned-route.png"/>
           <p:cNvPicPr>
             <a:picLocks noChangeAspect="1"/>
           </p:cNvPicPr>
@@ -5236,8 +5236,8 @@
         </p:blipFill>
         <p:spPr>
           <a:xfrm>
-            <a:off x="1306677" y="2313432"/>
-            <a:ext cx="6174028" cy="3858768"/>
+            <a:off x="963676" y="2313432"/>
+            <a:ext cx="6860031" cy="3858768"/>
           </a:xfrm>
           <a:prstGeom prst="rect">
             <a:avLst/>
@@ -5682,7 +5682,7 @@
               </a:defRPr>
             </a:pPr>
             <a:r>
-              <a:t>Goal 005 draft · live acceptance in progress</a:t>
+              <a:t>Goal 005 · one final-candidate Voice pass</a:t>
             </a:r>
           </a:p>
         </p:txBody>
@@ -5731,7 +5731,7 @@
       </p:sp>
       <p:pic>
         <p:nvPicPr>
-          <p:cNvPr id="8" name="Picture 7" descr="goal-005-gallery-zoom-chromium-1280.png"/>
+          <p:cNvPr id="8" name="Picture 7" descr="final-historical-dynamic-stable-clue.png"/>
           <p:cNvPicPr>
             <a:picLocks noChangeAspect="1"/>
           </p:cNvPicPr>
@@ -6084,7 +6084,7 @@
               </a:defRPr>
             </a:pPr>
             <a:r>
-              <a:t>A COMPANION THAT HELPS YOU ORIENT</a:t>
+              <a:t>AN ACTUAL RESCUE</a:t>
             </a:r>
           </a:p>
         </p:txBody>
@@ -6126,7 +6126,7 @@
               </a:defRPr>
             </a:pPr>
             <a:r>
-              <a:t>“I moved” should not be the end of the exchange.</a:t>
+              <a:t>A blocked passage can change the route.</a:t>
             </a:r>
           </a:p>
         </p:txBody>
@@ -6168,7 +6168,7 @@
               </a:defRPr>
             </a:pPr>
             <a:r>
-              <a:t>Goal 005 connects a confirmed arrival to a useful local report.</a:t>
+              <a:t>Real Voice attempt 12: a backtrack, a recovered request, and confirmed home.</a:t>
             </a:r>
           </a:p>
         </p:txBody>
@@ -6210,7 +6210,7 @@
               </a:defRPr>
             </a:pPr>
             <a:r>
-              <a:t>Goal 005 draft · live acceptance in progress</a:t>
+              <a:t>Goal 005 · one final-candidate Voice pass</a:t>
             </a:r>
           </a:p>
         </p:txBody>
@@ -6257,49 +6257,30 @@
           </a:p>
         </p:txBody>
       </p:sp>
-      <p:sp>
-        <p:nvSpPr>
-          <p:cNvPr id="8" name="Rectangle 7"/>
-          <p:cNvSpPr/>
+      <p:pic>
+        <p:nvPicPr>
+          <p:cNvPr id="8" name="Picture 7" descr="attempt-12-observed-home.png"/>
+          <p:cNvPicPr>
+            <a:picLocks noChangeAspect="1"/>
+          </p:cNvPicPr>
           <p:nvPr/>
-        </p:nvSpPr>
-        <p:spPr>
-          <a:xfrm>
-            <a:off x="621792" y="2551176"/>
-            <a:ext cx="3227832" cy="2898648"/>
+        </p:nvPicPr>
+        <p:blipFill>
+          <a:blip r:embed="rId2"/>
+          <a:stretch>
+            <a:fillRect/>
+          </a:stretch>
+        </p:blipFill>
+        <p:spPr>
+          <a:xfrm>
+            <a:off x="1215237" y="2304288"/>
+            <a:ext cx="6174028" cy="3858768"/>
           </a:xfrm>
           <a:prstGeom prst="rect">
             <a:avLst/>
           </a:prstGeom>
-          <a:solidFill>
-            <a:srgbClr val="E4E9DD"/>
-          </a:solidFill>
-          <a:ln>
-            <a:noFill/>
-          </a:ln>
-        </p:spPr>
-        <p:style>
-          <a:lnRef idx="1">
-            <a:schemeClr val="accent1"/>
-          </a:lnRef>
-          <a:fillRef idx="3">
-            <a:schemeClr val="accent1"/>
-          </a:fillRef>
-          <a:effectRef idx="2">
-            <a:schemeClr val="accent1"/>
-          </a:effectRef>
-          <a:fontRef idx="minor">
-            <a:schemeClr val="lt1"/>
-          </a:fontRef>
-        </p:style>
-        <p:txBody>
-          <a:bodyPr rtlCol="0" anchor="ctr"/>
-          <a:lstStyle/>
-          <a:p>
-            <a:pPr algn="ctr"/>
-          </a:p>
-        </p:txBody>
-      </p:sp>
+        </p:spPr>
+      </p:pic>
       <p:sp>
         <p:nvSpPr>
           <p:cNvPr id="9" name="TextBox 8"/>
@@ -6308,8 +6289,8 @@
         </p:nvSpPr>
         <p:spPr>
           <a:xfrm>
-            <a:off x="832104" y="2843784"/>
-            <a:ext cx="2834640" cy="347472"/>
+            <a:off x="8275320" y="2587752"/>
+            <a:ext cx="3246120" cy="365760"/>
           </a:xfrm>
           <a:prstGeom prst="rect">
             <a:avLst/>
@@ -6329,7 +6310,7 @@
               <a:spcAft>
                 <a:spcPts val="900"/>
               </a:spcAft>
-              <a:defRPr sz="1200" b="1">
+              <a:defRPr sz="1300" b="1">
                 <a:solidFill>
                   <a:srgbClr val="557862"/>
                 </a:solidFill>
@@ -6337,7 +6318,7 @@
               </a:defRPr>
             </a:pPr>
             <a:r>
-              <a:t>1  CONFIRMED ARRIVAL</a:t>
+              <a:t>ONE COMPLETE RESCUE</a:t>
             </a:r>
           </a:p>
         </p:txBody>
@@ -6350,418 +6331,8 @@
         </p:nvSpPr>
         <p:spPr>
           <a:xfrm>
-            <a:off x="832104" y="3502152"/>
-            <a:ext cx="2807208" cy="1645920"/>
-          </a:xfrm>
-          <a:prstGeom prst="rect">
-            <a:avLst/>
-          </a:prstGeom>
-          <a:noFill/>
-        </p:spPr>
-        <p:txBody>
-          <a:bodyPr wrap="square" lIns="0" rIns="0" tIns="0" bIns="0">
-            <a:spAutoFit/>
-          </a:bodyPr>
-          <a:lstStyle/>
-          <a:p>
-            <a:pPr>
-              <a:lnSpc>
-                <a:spcPct val="108000"/>
-              </a:lnSpc>
-              <a:spcAft>
-                <a:spcPts val="900"/>
-              </a:spcAft>
-              <a:defRPr sz="1800" b="0">
-                <a:solidFill>
-                  <a:srgbClr val="24382F"/>
-                </a:solidFill>
-                <a:latin typeface="Liberation Sans"/>
-              </a:defRPr>
-            </a:pPr>
-            <a:r>
-              <a:t>One confirmed action.</a:t>
-            </a:r>
-          </a:p>
-          <a:p>
-            <a:pPr>
-              <a:lnSpc>
-                <a:spcPct val="108000"/>
-              </a:lnSpc>
-              <a:spcAft>
-                <a:spcPts val="900"/>
-              </a:spcAft>
-              <a:defRPr sz="1800" b="0">
-                <a:solidFill>
-                  <a:srgbClr val="24382F"/>
-                </a:solidFill>
-                <a:latin typeface="Liberation Sans"/>
-              </a:defRPr>
-            </a:pPr>
-            <a:r>
-              <a:t>A scoped local observation.</a:t>
-            </a:r>
-          </a:p>
-          <a:p>
-            <a:pPr>
-              <a:lnSpc>
-                <a:spcPct val="108000"/>
-              </a:lnSpc>
-              <a:spcAft>
-                <a:spcPts val="900"/>
-              </a:spcAft>
-              <a:defRPr sz="1800" b="0">
-                <a:solidFill>
-                  <a:srgbClr val="24382F"/>
-                </a:solidFill>
-                <a:latin typeface="Liberation Sans"/>
-              </a:defRPr>
-            </a:pPr>
-            <a:r>
-              <a:t>Its source and time retained.</a:t>
-            </a:r>
-          </a:p>
-        </p:txBody>
-      </p:sp>
-      <p:sp>
-        <p:nvSpPr>
-          <p:cNvPr id="11" name="Rectangle 10"/>
-          <p:cNvSpPr/>
-          <p:nvPr/>
-        </p:nvSpPr>
-        <p:spPr>
-          <a:xfrm>
-            <a:off x="4480560" y="2551176"/>
-            <a:ext cx="3227832" cy="2898648"/>
-          </a:xfrm>
-          <a:prstGeom prst="rect">
-            <a:avLst/>
-          </a:prstGeom>
-          <a:solidFill>
-            <a:srgbClr val="E8E1CF"/>
-          </a:solidFill>
-          <a:ln>
-            <a:noFill/>
-          </a:ln>
-        </p:spPr>
-        <p:style>
-          <a:lnRef idx="1">
-            <a:schemeClr val="accent1"/>
-          </a:lnRef>
-          <a:fillRef idx="3">
-            <a:schemeClr val="accent1"/>
-          </a:fillRef>
-          <a:effectRef idx="2">
-            <a:schemeClr val="accent1"/>
-          </a:effectRef>
-          <a:fontRef idx="minor">
-            <a:schemeClr val="lt1"/>
-          </a:fontRef>
-        </p:style>
-        <p:txBody>
-          <a:bodyPr rtlCol="0" anchor="ctr"/>
-          <a:lstStyle/>
-          <a:p>
-            <a:pPr algn="ctr"/>
-          </a:p>
-        </p:txBody>
-      </p:sp>
-      <p:sp>
-        <p:nvSpPr>
-          <p:cNvPr id="12" name="TextBox 11"/>
-          <p:cNvSpPr txBox="1"/>
-          <p:nvPr/>
-        </p:nvSpPr>
-        <p:spPr>
-          <a:xfrm>
-            <a:off x="4690872" y="2843784"/>
-            <a:ext cx="2834640" cy="347472"/>
-          </a:xfrm>
-          <a:prstGeom prst="rect">
-            <a:avLst/>
-          </a:prstGeom>
-          <a:noFill/>
-        </p:spPr>
-        <p:txBody>
-          <a:bodyPr wrap="square" lIns="0" rIns="0" tIns="0" bIns="0">
-            <a:spAutoFit/>
-          </a:bodyPr>
-          <a:lstStyle/>
-          <a:p>
-            <a:pPr>
-              <a:lnSpc>
-                <a:spcPct val="108000"/>
-              </a:lnSpc>
-              <a:spcAft>
-                <a:spcPts val="900"/>
-              </a:spcAft>
-              <a:defRPr sz="1200" b="1">
-                <a:solidFill>
-                  <a:srgbClr val="557862"/>
-                </a:solidFill>
-                <a:latin typeface="Liberation Sans"/>
-              </a:defRPr>
-            </a:pPr>
-            <a:r>
-              <a:t>2  USEFUL ORIENTATION</a:t>
-            </a:r>
-          </a:p>
-        </p:txBody>
-      </p:sp>
-      <p:sp>
-        <p:nvSpPr>
-          <p:cNvPr id="13" name="TextBox 12"/>
-          <p:cNvSpPr txBox="1"/>
-          <p:nvPr/>
-        </p:nvSpPr>
-        <p:spPr>
-          <a:xfrm>
-            <a:off x="4690872" y="3502152"/>
-            <a:ext cx="2807208" cy="1645920"/>
-          </a:xfrm>
-          <a:prstGeom prst="rect">
-            <a:avLst/>
-          </a:prstGeom>
-          <a:noFill/>
-        </p:spPr>
-        <p:txBody>
-          <a:bodyPr wrap="square" lIns="0" rIns="0" tIns="0" bIns="0">
-            <a:spAutoFit/>
-          </a:bodyPr>
-          <a:lstStyle/>
-          <a:p>
-            <a:pPr>
-              <a:lnSpc>
-                <a:spcPct val="108000"/>
-              </a:lnSpc>
-              <a:spcAft>
-                <a:spcPts val="900"/>
-              </a:spcAft>
-              <a:defRPr sz="1800" b="0">
-                <a:solidFill>
-                  <a:srgbClr val="24382F"/>
-                </a:solidFill>
-                <a:latin typeface="Liberation Sans"/>
-              </a:defRPr>
-            </a:pPr>
-            <a:r>
-              <a:t>Report the nearby emblem.</a:t>
-            </a:r>
-          </a:p>
-          <a:p>
-            <a:pPr>
-              <a:lnSpc>
-                <a:spcPct val="108000"/>
-              </a:lnSpc>
-              <a:spcAft>
-                <a:spcPts val="900"/>
-              </a:spcAft>
-              <a:defRPr sz="1800" b="0">
-                <a:solidFill>
-                  <a:srgbClr val="24382F"/>
-                </a:solidFill>
-                <a:latin typeface="Liberation Sans"/>
-              </a:defRPr>
-            </a:pPr>
-            <a:r>
-              <a:t>Name visible directions.</a:t>
-            </a:r>
-          </a:p>
-          <a:p>
-            <a:pPr>
-              <a:lnSpc>
-                <a:spcPct val="108000"/>
-              </a:lnSpc>
-              <a:spcAft>
-                <a:spcPts val="900"/>
-              </a:spcAft>
-              <a:defRPr sz="1800" b="0">
-                <a:solidFill>
-                  <a:srgbClr val="24382F"/>
-                </a:solidFill>
-                <a:latin typeface="Liberation Sans"/>
-              </a:defRPr>
-            </a:pPr>
-            <a:r>
-              <a:t>Keep the response bounded.</a:t>
-            </a:r>
-          </a:p>
-        </p:txBody>
-      </p:sp>
-      <p:sp>
-        <p:nvSpPr>
-          <p:cNvPr id="14" name="Rectangle 13"/>
-          <p:cNvSpPr/>
-          <p:nvPr/>
-        </p:nvSpPr>
-        <p:spPr>
-          <a:xfrm>
-            <a:off x="8339327" y="2551176"/>
-            <a:ext cx="3227832" cy="2898648"/>
-          </a:xfrm>
-          <a:prstGeom prst="rect">
-            <a:avLst/>
-          </a:prstGeom>
-          <a:solidFill>
-            <a:srgbClr val="E4E9DD"/>
-          </a:solidFill>
-          <a:ln>
-            <a:noFill/>
-          </a:ln>
-        </p:spPr>
-        <p:style>
-          <a:lnRef idx="1">
-            <a:schemeClr val="accent1"/>
-          </a:lnRef>
-          <a:fillRef idx="3">
-            <a:schemeClr val="accent1"/>
-          </a:fillRef>
-          <a:effectRef idx="2">
-            <a:schemeClr val="accent1"/>
-          </a:effectRef>
-          <a:fontRef idx="minor">
-            <a:schemeClr val="lt1"/>
-          </a:fontRef>
-        </p:style>
-        <p:txBody>
-          <a:bodyPr rtlCol="0" anchor="ctr"/>
-          <a:lstStyle/>
-          <a:p>
-            <a:pPr algn="ctr"/>
-          </a:p>
-        </p:txBody>
-      </p:sp>
-      <p:sp>
-        <p:nvSpPr>
-          <p:cNvPr id="15" name="TextBox 14"/>
-          <p:cNvSpPr txBox="1"/>
-          <p:nvPr/>
-        </p:nvSpPr>
-        <p:spPr>
-          <a:xfrm>
-            <a:off x="8549640" y="2843784"/>
-            <a:ext cx="2834640" cy="347472"/>
-          </a:xfrm>
-          <a:prstGeom prst="rect">
-            <a:avLst/>
-          </a:prstGeom>
-          <a:noFill/>
-        </p:spPr>
-        <p:txBody>
-          <a:bodyPr wrap="square" lIns="0" rIns="0" tIns="0" bIns="0">
-            <a:spAutoFit/>
-          </a:bodyPr>
-          <a:lstStyle/>
-          <a:p>
-            <a:pPr>
-              <a:lnSpc>
-                <a:spcPct val="108000"/>
-              </a:lnSpc>
-              <a:spcAft>
-                <a:spcPts val="900"/>
-              </a:spcAft>
-              <a:defRPr sz="1200" b="1">
-                <a:solidFill>
-                  <a:srgbClr val="557862"/>
-                </a:solidFill>
-                <a:latin typeface="Liberation Sans"/>
-              </a:defRPr>
-            </a:pPr>
-            <a:r>
-              <a:t>3  A HUMAN CHOICE</a:t>
-            </a:r>
-          </a:p>
-        </p:txBody>
-      </p:sp>
-      <p:sp>
-        <p:nvSpPr>
-          <p:cNvPr id="16" name="TextBox 15"/>
-          <p:cNvSpPr txBox="1"/>
-          <p:nvPr/>
-        </p:nvSpPr>
-        <p:spPr>
-          <a:xfrm>
-            <a:off x="8549640" y="3502152"/>
-            <a:ext cx="2807208" cy="1645920"/>
-          </a:xfrm>
-          <a:prstGeom prst="rect">
-            <a:avLst/>
-          </a:prstGeom>
-          <a:noFill/>
-        </p:spPr>
-        <p:txBody>
-          <a:bodyPr wrap="square" lIns="0" rIns="0" tIns="0" bIns="0">
-            <a:spAutoFit/>
-          </a:bodyPr>
-          <a:lstStyle/>
-          <a:p>
-            <a:pPr>
-              <a:lnSpc>
-                <a:spcPct val="108000"/>
-              </a:lnSpc>
-              <a:spcAft>
-                <a:spcPts val="900"/>
-              </a:spcAft>
-              <a:defRPr sz="1800" b="0">
-                <a:solidFill>
-                  <a:srgbClr val="24382F"/>
-                </a:solidFill>
-                <a:latin typeface="Liberation Sans"/>
-              </a:defRPr>
-            </a:pPr>
-            <a:r>
-              <a:t>Compare with the atlas.</a:t>
-            </a:r>
-          </a:p>
-          <a:p>
-            <a:pPr>
-              <a:lnSpc>
-                <a:spcPct val="108000"/>
-              </a:lnSpc>
-              <a:spcAft>
-                <a:spcPts val="900"/>
-              </a:spcAft>
-              <a:defRPr sz="1800" b="0">
-                <a:solidFill>
-                  <a:srgbClr val="24382F"/>
-                </a:solidFill>
-                <a:latin typeface="Liberation Sans"/>
-              </a:defRPr>
-            </a:pPr>
-            <a:r>
-              <a:t>Check an uncertain branch.</a:t>
-            </a:r>
-          </a:p>
-          <a:p>
-            <a:pPr>
-              <a:lnSpc>
-                <a:spcPct val="108000"/>
-              </a:lnSpc>
-              <a:spcAft>
-                <a:spcPts val="900"/>
-              </a:spcAft>
-              <a:defRPr sz="1800" b="0">
-                <a:solidFill>
-                  <a:srgbClr val="24382F"/>
-                </a:solidFill>
-                <a:latin typeface="Liberation Sans"/>
-              </a:defRPr>
-            </a:pPr>
-            <a:r>
-              <a:t>Replan without resetting.</a:t>
-            </a:r>
-          </a:p>
-        </p:txBody>
-      </p:sp>
-      <p:sp>
-        <p:nvSpPr>
-          <p:cNvPr id="17" name="TextBox 16"/>
-          <p:cNvSpPr txBox="1"/>
-          <p:nvPr/>
-        </p:nvSpPr>
-        <p:spPr>
-          <a:xfrm>
-            <a:off x="731520" y="5852160"/>
-            <a:ext cx="10881360" cy="484632"/>
+            <a:off x="8275320" y="3172968"/>
+            <a:ext cx="3246120" cy="1399032"/>
           </a:xfrm>
           <a:prstGeom prst="rect">
             <a:avLst/>
@@ -6783,13 +6354,112 @@
               </a:spcAft>
               <a:defRPr sz="1900" b="0">
                 <a:solidFill>
-                  <a:srgbClr val="557862"/>
+                  <a:srgbClr val="24382F"/>
                 </a:solidFill>
                 <a:latin typeface="Liberation Sans"/>
               </a:defRPr>
             </a:pPr>
             <a:r>
-              <a:t>Pause, Interrupt and End still win. A missing report leaves room to ask again.</a:t>
+              <a:t>Eleven exact confirmations.</a:t>
+            </a:r>
+          </a:p>
+          <a:p>
+            <a:pPr>
+              <a:lnSpc>
+                <a:spcPct val="108000"/>
+              </a:lnSpc>
+              <a:spcAft>
+                <a:spcPts val="900"/>
+              </a:spcAft>
+              <a:defRPr sz="1900" b="0">
+                <a:solidFill>
+                  <a:srgbClr val="24382F"/>
+                </a:solidFill>
+                <a:latin typeface="Liberation Sans"/>
+              </a:defRPr>
+            </a:pPr>
+            <a:r>
+              <a:t>Useful arrival reports.</a:t>
+            </a:r>
+          </a:p>
+          <a:p>
+            <a:pPr>
+              <a:lnSpc>
+                <a:spcPct val="108000"/>
+              </a:lnSpc>
+              <a:spcAft>
+                <a:spcPts val="900"/>
+              </a:spcAft>
+              <a:defRPr sz="1900" b="0">
+                <a:solidFill>
+                  <a:srgbClr val="24382F"/>
+                </a:solidFill>
+                <a:latin typeface="Liberation Sans"/>
+              </a:defRPr>
+            </a:pPr>
+            <a:r>
+              <a:t>A way around blocked cargo.</a:t>
+            </a:r>
+          </a:p>
+        </p:txBody>
+      </p:sp>
+      <p:sp>
+        <p:nvSpPr>
+          <p:cNvPr id="11" name="TextBox 10"/>
+          <p:cNvSpPr txBox="1"/>
+          <p:nvPr/>
+        </p:nvSpPr>
+        <p:spPr>
+          <a:xfrm>
+            <a:off x="8275320" y="5065776"/>
+            <a:ext cx="3246120" cy="731520"/>
+          </a:xfrm>
+          <a:prstGeom prst="rect">
+            <a:avLst/>
+          </a:prstGeom>
+          <a:noFill/>
+        </p:spPr>
+        <p:txBody>
+          <a:bodyPr wrap="square" lIns="0" rIns="0" tIns="0" bIns="0">
+            <a:spAutoFit/>
+          </a:bodyPr>
+          <a:lstStyle/>
+          <a:p>
+            <a:pPr>
+              <a:lnSpc>
+                <a:spcPct val="108000"/>
+              </a:lnSpc>
+              <a:spcAft>
+                <a:spcPts val="900"/>
+              </a:spcAft>
+              <a:defRPr sz="1700" b="0">
+                <a:solidFill>
+                  <a:srgbClr val="607066"/>
+                </a:solidFill>
+                <a:latin typeface="Liberation Sans"/>
+              </a:defRPr>
+            </a:pPr>
+            <a:r>
+              <a:t>Home, playback drain and</a:t>
+            </a:r>
+          </a:p>
+          <a:p>
+            <a:pPr>
+              <a:lnSpc>
+                <a:spcPct val="108000"/>
+              </a:lnSpc>
+              <a:spcAft>
+                <a:spcPts val="900"/>
+              </a:spcAft>
+              <a:defRPr sz="1700" b="0">
+                <a:solidFill>
+                  <a:srgbClr val="607066"/>
+                </a:solidFill>
+                <a:latin typeface="Liberation Sans"/>
+              </a:defRPr>
+            </a:pPr>
+            <a:r>
+              <a:t>ending ACK observed.</a:t>
             </a:r>
           </a:p>
         </p:txBody>
@@ -6942,7 +6612,7 @@
               </a:defRPr>
             </a:pPr>
             <a:r>
-              <a:t>The final live result is still being established.</a:t>
+              <a:t>Home reached. Reliability still needs work.</a:t>
             </a:r>
           </a:p>
         </p:txBody>
@@ -6984,7 +6654,7 @@
               </a:defRPr>
             </a:pPr>
             <a:r>
-              <a:t>Goal 005 draft · live acceptance in progress</a:t>
+              <a:t>Goal 005 · one final-candidate Voice pass</a:t>
             </a:r>
           </a:p>
         </p:txBody>
@@ -7153,7 +6823,26 @@
               </a:defRPr>
             </a:pPr>
             <a:r>
-              <a:t>Current images show deterministic Practice. Final-candidate Voice completion, recovery and ending evidence will replace this status after the approved batch.</a:t>
+              <a:t>One final-candidate Voice rescue reached home with 11 exact confirmations and an ending ACK.</a:t>
+            </a:r>
+          </a:p>
+          <a:p>
+            <a:pPr>
+              <a:lnSpc>
+                <a:spcPct val="108000"/>
+              </a:lnSpc>
+              <a:spcAft>
+                <a:spcPts val="900"/>
+              </a:spcAft>
+              <a:defRPr sz="2200" b="0">
+                <a:solidFill>
+                  <a:srgbClr val="24382F"/>
+                </a:solidFill>
+                <a:latin typeface="Liberation Sans"/>
+              </a:defRPr>
+            </a:pPr>
+            <a:r>
+              <a:t>A second run stalled in the Gallery without an ACK. The two-pass target remains unmet.</a:t>
             </a:r>
           </a:p>
         </p:txBody>
@@ -7378,7 +7067,7 @@
               </a:defRPr>
             </a:pPr>
             <a:r>
-              <a:t>Evidence: artifacts/goal-005/ui/gallery-validation.json</a:t>
+              <a:t>Evidence: docs/goal-005-gallery-live-completion.md</a:t>
             </a:r>
           </a:p>
         </p:txBody>

</xml_diff>